<commit_message>
docs: Updated Proposal and Presentation Decks with Free AI Media Studio and Odysseus.ai benchmark
</commit_message>
<xml_diff>
--- a/SLIDES.pptx
+++ b/SLIDES.pptx
@@ -4380,7 +4380,7 @@
                         </a:defRPr>
                       </a:pPr>
                       <a:r>
-                        <a:t>Statically Linked .exe / .msi</a:t>
+                        <a:t>Statically Linked .exe (11.9MB)</a:t>
                       </a:r>
                     </a:p>
                   </a:txBody>
@@ -5039,7 +5039,7 @@
               </a:defRPr>
             </a:pPr>
             <a:r>
-              <a:t>friday-diagnostics</a:t>
+              <a:t>friday-generator</a:t>
             </a:r>
           </a:p>
           <a:p>
@@ -5051,7 +5051,7 @@
               </a:defRPr>
             </a:pPr>
             <a:r>
-              <a:t>Compiler auto-debugging loop</a:t>
+              <a:t>100% Free AI Media Studio Engine</a:t>
             </a:r>
           </a:p>
         </p:txBody>
@@ -6120,7 +6120,7 @@
               </a:defRPr>
             </a:pPr>
             <a:r>
-              <a:t>USER INTERFACE</a:t>
+              <a:t>GENERATIVE CAPABILITIES</a:t>
             </a:r>
           </a:p>
           <a:p>
@@ -6133,7 +6133,7 @@
               </a:defRPr>
             </a:pPr>
             <a:r>
-              <a:t>Embedded Glassmorphic Developer Control Console</a:t>
+              <a:t>100% Free AI Image &amp; Video Media Studio</a:t>
             </a:r>
           </a:p>
         </p:txBody>
@@ -6230,7 +6230,7 @@
               </a:defRPr>
             </a:pPr>
             <a:r>
-              <a:t>💻 Axum Web Server Features</a:t>
+              <a:t>🖼️ FLUX.1 Artwork Generation</a:t>
             </a:r>
           </a:p>
           <a:p>
@@ -6243,7 +6243,7 @@
               </a:defRPr>
             </a:pPr>
             <a:r>
-              <a:t>• Embedded directly inside binary (std::include_str!).</a:t>
+              <a:t>• 100% Free FLUX.1-schnell 1024x1024 artwork generation.</a:t>
             </a:r>
           </a:p>
           <a:p>
@@ -6256,7 +6256,7 @@
               </a:defRPr>
             </a:pPr>
             <a:r>
-              <a:t>• Live CPU &amp; RAM telemetry progress bars.</a:t>
+              <a:t>• Zero API keys, credit cards or subscriptions required.</a:t>
             </a:r>
           </a:p>
           <a:p>
@@ -6269,7 +6269,7 @@
               </a:defRPr>
             </a:pPr>
             <a:r>
-              <a:t>• Interactive Claude Code-style shell console.</a:t>
+              <a:t>• Instant HTTP inference saving local .jpg files.</a:t>
             </a:r>
           </a:p>
           <a:p>
@@ -6282,20 +6282,7 @@
               </a:defRPr>
             </a:pPr>
             <a:r>
-              <a:t>• Active browser simulation viewport frame.</a:t>
-            </a:r>
-          </a:p>
-          <a:p>
-            <a:br/>
-            <a:pPr>
-              <a:defRPr sz="1100">
-                <a:solidFill>
-                  <a:srgbClr val="FFFFFF"/>
-                </a:solidFill>
-              </a:defRPr>
-            </a:pPr>
-            <a:r>
-              <a:t>• Zero-dependency single executable launch.</a:t>
+              <a:t>• Interactive Media Studio tab in Web Dashboard.</a:t>
             </a:r>
           </a:p>
         </p:txBody>
@@ -6349,7 +6336,7 @@
               </a:defRPr>
             </a:pPr>
             <a:r>
-              <a:t>🌐 Web Deployment Strategy</a:t>
+              <a:t>🎬 AnimateDiff AI Video Engine</a:t>
             </a:r>
           </a:p>
           <a:p>
@@ -6362,7 +6349,7 @@
               </a:defRPr>
             </a:pPr>
             <a:r>
-              <a:t>• GitHub Pages: Live interactive sandbox served at index.html.</a:t>
+              <a:t>• Text-to-Video animation frame flow sequences.</a:t>
             </a:r>
           </a:p>
           <a:p>
@@ -6375,7 +6362,7 @@
               </a:defRPr>
             </a:pPr>
             <a:r>
-              <a:t>• Vercel Deployment: Automatic static site deployment out of the box.</a:t>
+              <a:t>• Local ComfyUI / Automatic1111 bridge (100% Offline).</a:t>
             </a:r>
           </a:p>
           <a:p>
@@ -6388,7 +6375,7 @@
               </a:defRPr>
             </a:pPr>
             <a:r>
-              <a:t>• Educational &amp; Security Info: Built-in guides for developer safety.</a:t>
+              <a:t>• Prompt Enhancer auto-optimizes token density for visual quality.</a:t>
             </a:r>
           </a:p>
         </p:txBody>
@@ -6485,7 +6472,7 @@
               </a:defRPr>
             </a:pPr>
             <a:r>
-              <a:t>PERFORMANCE</a:t>
+              <a:t>MARKET ANALYSIS</a:t>
             </a:r>
           </a:p>
           <a:p>
@@ -6498,7 +6485,7 @@
               </a:defRPr>
             </a:pPr>
             <a:r>
-              <a:t>Ultra-High Speed Release Benchmarks</a:t>
+              <a:t>Competitive Advantage: Friday AI vs. Odysseus.ai</a:t>
             </a:r>
           </a:p>
         </p:txBody>
@@ -6546,318 +6533,598 @@
           </a:p>
         </p:txBody>
       </p:sp>
-      <p:sp>
-        <p:nvSpPr>
-          <p:cNvPr id="5" name="Rounded Rectangle 4"/>
-          <p:cNvSpPr/>
+      <p:graphicFrame>
+        <p:nvGraphicFramePr>
+          <p:cNvPr id="5" name="Table 4"/>
+          <p:cNvGraphicFramePr>
+            <a:graphicFrameLocks noGrp="1"/>
+          </p:cNvGraphicFramePr>
           <p:nvPr/>
-        </p:nvSpPr>
-        <p:spPr>
-          <a:xfrm>
-            <a:off x="731520" y="1645920"/>
-            <a:ext cx="5212080" cy="2011680"/>
-          </a:xfrm>
-          <a:prstGeom prst="roundRect">
-            <a:avLst/>
-          </a:prstGeom>
-          <a:solidFill>
-            <a:srgbClr val="1E293B"/>
-          </a:solidFill>
-          <a:ln>
-            <a:solidFill>
-              <a:srgbClr val="0EA5E9"/>
-            </a:solidFill>
-          </a:ln>
-        </p:spPr>
-        <p:style>
-          <a:lnRef idx="1">
-            <a:schemeClr val="accent1"/>
-          </a:lnRef>
-          <a:fillRef idx="3">
-            <a:schemeClr val="accent1"/>
-          </a:fillRef>
-          <a:effectRef idx="2">
-            <a:schemeClr val="accent1"/>
-          </a:effectRef>
-          <a:fontRef idx="minor">
-            <a:schemeClr val="lt1"/>
-          </a:fontRef>
-        </p:style>
-        <p:txBody>
-          <a:bodyPr rtlCol="0" anchor="ctr" wrap="square"/>
-          <a:lstStyle/>
-          <a:p>
-            <a:pPr algn="ctr">
-              <a:defRPr b="1" sz="3200">
-                <a:solidFill>
-                  <a:srgbClr val="06B6D4"/>
-                </a:solidFill>
-              </a:defRPr>
-            </a:pPr>
-            <a:r>
-              <a:t>1,000,000</a:t>
-            </a:r>
-          </a:p>
-          <a:p>
-            <a:pPr>
-              <a:defRPr b="1" sz="1400">
-                <a:solidFill>
-                  <a:srgbClr val="FFFFFF"/>
-                </a:solidFill>
-              </a:defRPr>
-            </a:pPr>
-            <a:r>
-              <a:t>Text Iteration Loops</a:t>
-            </a:r>
-          </a:p>
-          <a:p>
-            <a:pPr>
-              <a:defRPr sz="1100">
-                <a:solidFill>
-                  <a:srgbClr val="94A3B8"/>
-                </a:solidFill>
-              </a:defRPr>
-            </a:pPr>
-            <a:r>
-              <a:t>Processed speech anomaly filler checks</a:t>
-            </a:r>
-          </a:p>
-        </p:txBody>
-      </p:sp>
-      <p:sp>
-        <p:nvSpPr>
-          <p:cNvPr id="6" name="Rounded Rectangle 5"/>
-          <p:cNvSpPr/>
-          <p:nvPr/>
-        </p:nvSpPr>
-        <p:spPr>
-          <a:xfrm>
-            <a:off x="6126480" y="1645920"/>
-            <a:ext cx="5212080" cy="2011680"/>
-          </a:xfrm>
-          <a:prstGeom prst="roundRect">
-            <a:avLst/>
-          </a:prstGeom>
-          <a:solidFill>
-            <a:srgbClr val="1E293B"/>
-          </a:solidFill>
-          <a:ln>
-            <a:solidFill>
-              <a:srgbClr val="0EA5E9"/>
-            </a:solidFill>
-          </a:ln>
-        </p:spPr>
-        <p:style>
-          <a:lnRef idx="1">
-            <a:schemeClr val="accent1"/>
-          </a:lnRef>
-          <a:fillRef idx="3">
-            <a:schemeClr val="accent1"/>
-          </a:fillRef>
-          <a:effectRef idx="2">
-            <a:schemeClr val="accent1"/>
-          </a:effectRef>
-          <a:fontRef idx="minor">
-            <a:schemeClr val="lt1"/>
-          </a:fontRef>
-        </p:style>
-        <p:txBody>
-          <a:bodyPr rtlCol="0" anchor="ctr" wrap="square"/>
-          <a:lstStyle/>
-          <a:p>
-            <a:pPr algn="ctr">
-              <a:defRPr b="1" sz="3200">
-                <a:solidFill>
-                  <a:srgbClr val="06B6D4"/>
-                </a:solidFill>
-              </a:defRPr>
-            </a:pPr>
-            <a:r>
-              <a:t>200 ms</a:t>
-            </a:r>
-          </a:p>
-          <a:p>
-            <a:pPr>
-              <a:defRPr b="1" sz="1400">
-                <a:solidFill>
-                  <a:srgbClr val="FFFFFF"/>
-                </a:solidFill>
-              </a:defRPr>
-            </a:pPr>
-            <a:r>
-              <a:t>Total Execution Latency</a:t>
-            </a:r>
-          </a:p>
-          <a:p>
-            <a:pPr>
-              <a:defRPr sz="1100">
-                <a:solidFill>
-                  <a:srgbClr val="94A3B8"/>
-                </a:solidFill>
-              </a:defRPr>
-            </a:pPr>
-            <a:r>
-              <a:t>Completed in one-fifth of a second</a:t>
-            </a:r>
-          </a:p>
-        </p:txBody>
-      </p:sp>
-      <p:sp>
-        <p:nvSpPr>
-          <p:cNvPr id="7" name="Rounded Rectangle 6"/>
-          <p:cNvSpPr/>
-          <p:nvPr/>
-        </p:nvSpPr>
-        <p:spPr>
-          <a:xfrm>
-            <a:off x="731520" y="3931920"/>
-            <a:ext cx="5212080" cy="2011680"/>
-          </a:xfrm>
-          <a:prstGeom prst="roundRect">
-            <a:avLst/>
-          </a:prstGeom>
-          <a:solidFill>
-            <a:srgbClr val="1E293B"/>
-          </a:solidFill>
-          <a:ln>
-            <a:solidFill>
-              <a:srgbClr val="0EA5E9"/>
-            </a:solidFill>
-          </a:ln>
-        </p:spPr>
-        <p:style>
-          <a:lnRef idx="1">
-            <a:schemeClr val="accent1"/>
-          </a:lnRef>
-          <a:fillRef idx="3">
-            <a:schemeClr val="accent1"/>
-          </a:fillRef>
-          <a:effectRef idx="2">
-            <a:schemeClr val="accent1"/>
-          </a:effectRef>
-          <a:fontRef idx="minor">
-            <a:schemeClr val="lt1"/>
-          </a:fontRef>
-        </p:style>
-        <p:txBody>
-          <a:bodyPr rtlCol="0" anchor="ctr" wrap="square"/>
-          <a:lstStyle/>
-          <a:p>
-            <a:pPr algn="ctr">
-              <a:defRPr b="1" sz="3200">
-                <a:solidFill>
-                  <a:srgbClr val="06B6D4"/>
-                </a:solidFill>
-              </a:defRPr>
-            </a:pPr>
-            <a:r>
-              <a:t>0.0002 ms</a:t>
-            </a:r>
-          </a:p>
-          <a:p>
-            <a:pPr>
-              <a:defRPr b="1" sz="1400">
-                <a:solidFill>
-                  <a:srgbClr val="FFFFFF"/>
-                </a:solidFill>
-              </a:defRPr>
-            </a:pPr>
-            <a:r>
-              <a:t>Average Iteration Speed</a:t>
-            </a:r>
-          </a:p>
-          <a:p>
-            <a:pPr>
-              <a:defRPr sz="1100">
-                <a:solidFill>
-                  <a:srgbClr val="94A3B8"/>
-                </a:solidFill>
-              </a:defRPr>
-            </a:pPr>
-            <a:r>
-              <a:t>Native Rust compiled speed</a:t>
-            </a:r>
-          </a:p>
-        </p:txBody>
-      </p:sp>
-      <p:sp>
-        <p:nvSpPr>
-          <p:cNvPr id="8" name="Rounded Rectangle 7"/>
-          <p:cNvSpPr/>
-          <p:nvPr/>
-        </p:nvSpPr>
-        <p:spPr>
-          <a:xfrm>
-            <a:off x="6126480" y="3931920"/>
-            <a:ext cx="5212080" cy="2011680"/>
-          </a:xfrm>
-          <a:prstGeom prst="roundRect">
-            <a:avLst/>
-          </a:prstGeom>
-          <a:solidFill>
-            <a:srgbClr val="1E293B"/>
-          </a:solidFill>
-          <a:ln>
-            <a:solidFill>
-              <a:srgbClr val="0EA5E9"/>
-            </a:solidFill>
-          </a:ln>
-        </p:spPr>
-        <p:style>
-          <a:lnRef idx="1">
-            <a:schemeClr val="accent1"/>
-          </a:lnRef>
-          <a:fillRef idx="3">
-            <a:schemeClr val="accent1"/>
-          </a:fillRef>
-          <a:effectRef idx="2">
-            <a:schemeClr val="accent1"/>
-          </a:effectRef>
-          <a:fontRef idx="minor">
-            <a:schemeClr val="lt1"/>
-          </a:fontRef>
-        </p:style>
-        <p:txBody>
-          <a:bodyPr rtlCol="0" anchor="ctr" wrap="square"/>
-          <a:lstStyle/>
-          <a:p>
-            <a:pPr algn="ctr">
-              <a:defRPr b="1" sz="3200">
-                <a:solidFill>
-                  <a:srgbClr val="06B6D4"/>
-                </a:solidFill>
-              </a:defRPr>
-            </a:pPr>
-            <a:r>
-              <a:t>73.17%</a:t>
-            </a:r>
-          </a:p>
-          <a:p>
-            <a:pPr>
-              <a:defRPr b="1" sz="1400">
-                <a:solidFill>
-                  <a:srgbClr val="FFFFFF"/>
-                </a:solidFill>
-              </a:defRPr>
-            </a:pPr>
-            <a:r>
-              <a:t>System CPU Utilization</a:t>
-            </a:r>
-          </a:p>
-          <a:p>
-            <a:pPr>
-              <a:defRPr sz="1100">
-                <a:solidFill>
-                  <a:srgbClr val="94A3B8"/>
-                </a:solidFill>
-              </a:defRPr>
-            </a:pPr>
-            <a:r>
-              <a:t>Optimal multi-threaded load</a:t>
-            </a:r>
-          </a:p>
-        </p:txBody>
-      </p:sp>
+        </p:nvGraphicFramePr>
+        <p:xfrm>
+          <a:off x="731520" y="1645920"/>
+          <a:ext cx="10728655" cy="4389120"/>
+        </p:xfrm>
+        <a:graphic>
+          <a:graphicData uri="http://schemas.openxmlformats.org/drawingml/2006/table">
+            <a:tbl>
+              <a:tblPr firstRow="1" bandRow="1">
+                <a:tableStyleId>{5C22544A-7EE6-4342-B048-85BDC9FD1C3A}</a:tableStyleId>
+              </a:tblPr>
+              <a:tblGrid>
+                <a:gridCol w="2682163"/>
+                <a:gridCol w="2682163"/>
+                <a:gridCol w="2682163"/>
+                <a:gridCol w="2682166"/>
+              </a:tblGrid>
+              <a:tr h="731520">
+                <a:tc>
+                  <a:txBody>
+                    <a:bodyPr/>
+                    <a:lstStyle/>
+                    <a:p>
+                      <a:pPr>
+                        <a:defRPr b="1" sz="1200">
+                          <a:solidFill>
+                            <a:srgbClr val="0F172A"/>
+                          </a:solidFill>
+                        </a:defRPr>
+                      </a:pPr>
+                      <a:r>
+                        <a:t>Metric / Feature</a:t>
+                      </a:r>
+                    </a:p>
+                  </a:txBody>
+                  <a:tcPr>
+                    <a:solidFill>
+                      <a:srgbClr val="06B6D4"/>
+                    </a:solidFill>
+                  </a:tcPr>
+                </a:tc>
+                <a:tc>
+                  <a:txBody>
+                    <a:bodyPr/>
+                    <a:lstStyle/>
+                    <a:p>
+                      <a:pPr>
+                        <a:defRPr b="1" sz="1200">
+                          <a:solidFill>
+                            <a:srgbClr val="0F172A"/>
+                          </a:solidFill>
+                        </a:defRPr>
+                      </a:pPr>
+                      <a:r>
+                        <a:t>Friday AI (This Project)</a:t>
+                      </a:r>
+                    </a:p>
+                  </a:txBody>
+                  <a:tcPr>
+                    <a:solidFill>
+                      <a:srgbClr val="06B6D4"/>
+                    </a:solidFill>
+                  </a:tcPr>
+                </a:tc>
+                <a:tc>
+                  <a:txBody>
+                    <a:bodyPr/>
+                    <a:lstStyle/>
+                    <a:p>
+                      <a:pPr>
+                        <a:defRPr b="1" sz="1200">
+                          <a:solidFill>
+                            <a:srgbClr val="0F172A"/>
+                          </a:solidFill>
+                        </a:defRPr>
+                      </a:pPr>
+                      <a:r>
+                        <a:t>Odysseus.ai (PewDiePie)</a:t>
+                      </a:r>
+                    </a:p>
+                  </a:txBody>
+                  <a:tcPr>
+                    <a:solidFill>
+                      <a:srgbClr val="06B6D4"/>
+                    </a:solidFill>
+                  </a:tcPr>
+                </a:tc>
+                <a:tc>
+                  <a:txBody>
+                    <a:bodyPr/>
+                    <a:lstStyle/>
+                    <a:p>
+                      <a:pPr>
+                        <a:defRPr b="1" sz="1200">
+                          <a:solidFill>
+                            <a:srgbClr val="0F172A"/>
+                          </a:solidFill>
+                        </a:defRPr>
+                      </a:pPr>
+                      <a:r>
+                        <a:t>OpenInterpreter</a:t>
+                      </a:r>
+                    </a:p>
+                  </a:txBody>
+                  <a:tcPr>
+                    <a:solidFill>
+                      <a:srgbClr val="06B6D4"/>
+                    </a:solidFill>
+                  </a:tcPr>
+                </a:tc>
+              </a:tr>
+              <a:tr h="731520">
+                <a:tc>
+                  <a:txBody>
+                    <a:bodyPr/>
+                    <a:lstStyle/>
+                    <a:p>
+                      <a:pPr>
+                        <a:defRPr sz="1100">
+                          <a:solidFill>
+                            <a:srgbClr val="FFFFFF"/>
+                          </a:solidFill>
+                        </a:defRPr>
+                      </a:pPr>
+                      <a:r>
+                        <a:t>Core Runtime</a:t>
+                      </a:r>
+                    </a:p>
+                  </a:txBody>
+                  <a:tcPr>
+                    <a:solidFill>
+                      <a:srgbClr val="1E293B"/>
+                    </a:solidFill>
+                  </a:tcPr>
+                </a:tc>
+                <a:tc>
+                  <a:txBody>
+                    <a:bodyPr/>
+                    <a:lstStyle/>
+                    <a:p>
+                      <a:pPr>
+                        <a:defRPr sz="1100">
+                          <a:solidFill>
+                            <a:srgbClr val="06B6D4"/>
+                          </a:solidFill>
+                        </a:defRPr>
+                      </a:pPr>
+                      <a:r>
+                        <a:t>100% Compiled Rust</a:t>
+                      </a:r>
+                    </a:p>
+                  </a:txBody>
+                  <a:tcPr>
+                    <a:solidFill>
+                      <a:srgbClr val="0F2D4B"/>
+                    </a:solidFill>
+                  </a:tcPr>
+                </a:tc>
+                <a:tc>
+                  <a:txBody>
+                    <a:bodyPr/>
+                    <a:lstStyle/>
+                    <a:p>
+                      <a:pPr>
+                        <a:defRPr sz="1100">
+                          <a:solidFill>
+                            <a:srgbClr val="FFFFFF"/>
+                          </a:solidFill>
+                        </a:defRPr>
+                      </a:pPr>
+                      <a:r>
+                        <a:t>Electron / Node.js</a:t>
+                      </a:r>
+                    </a:p>
+                  </a:txBody>
+                  <a:tcPr>
+                    <a:solidFill>
+                      <a:srgbClr val="1E293B"/>
+                    </a:solidFill>
+                  </a:tcPr>
+                </a:tc>
+                <a:tc>
+                  <a:txBody>
+                    <a:bodyPr/>
+                    <a:lstStyle/>
+                    <a:p>
+                      <a:pPr>
+                        <a:defRPr sz="1100">
+                          <a:solidFill>
+                            <a:srgbClr val="FFFFFF"/>
+                          </a:solidFill>
+                        </a:defRPr>
+                      </a:pPr>
+                      <a:r>
+                        <a:t>Python CLI</a:t>
+                      </a:r>
+                    </a:p>
+                  </a:txBody>
+                  <a:tcPr>
+                    <a:solidFill>
+                      <a:srgbClr val="1E293B"/>
+                    </a:solidFill>
+                  </a:tcPr>
+                </a:tc>
+              </a:tr>
+              <a:tr h="731520">
+                <a:tc>
+                  <a:txBody>
+                    <a:bodyPr/>
+                    <a:lstStyle/>
+                    <a:p>
+                      <a:pPr>
+                        <a:defRPr sz="1100">
+                          <a:solidFill>
+                            <a:srgbClr val="FFFFFF"/>
+                          </a:solidFill>
+                        </a:defRPr>
+                      </a:pPr>
+                      <a:r>
+                        <a:t>Binary Size</a:t>
+                      </a:r>
+                    </a:p>
+                  </a:txBody>
+                  <a:tcPr>
+                    <a:solidFill>
+                      <a:srgbClr val="1E293B"/>
+                    </a:solidFill>
+                  </a:tcPr>
+                </a:tc>
+                <a:tc>
+                  <a:txBody>
+                    <a:bodyPr/>
+                    <a:lstStyle/>
+                    <a:p>
+                      <a:pPr>
+                        <a:defRPr sz="1100">
+                          <a:solidFill>
+                            <a:srgbClr val="06B6D4"/>
+                          </a:solidFill>
+                        </a:defRPr>
+                      </a:pPr>
+                      <a:r>
+                        <a:t>11.9 MB (Single Binary)</a:t>
+                      </a:r>
+                    </a:p>
+                  </a:txBody>
+                  <a:tcPr>
+                    <a:solidFill>
+                      <a:srgbClr val="0F2D4B"/>
+                    </a:solidFill>
+                  </a:tcPr>
+                </a:tc>
+                <a:tc>
+                  <a:txBody>
+                    <a:bodyPr/>
+                    <a:lstStyle/>
+                    <a:p>
+                      <a:pPr>
+                        <a:defRPr sz="1100">
+                          <a:solidFill>
+                            <a:srgbClr val="FFFFFF"/>
+                          </a:solidFill>
+                        </a:defRPr>
+                      </a:pPr>
+                      <a:r>
+                        <a:t>~250 MB (Electron App)</a:t>
+                      </a:r>
+                    </a:p>
+                  </a:txBody>
+                  <a:tcPr>
+                    <a:solidFill>
+                      <a:srgbClr val="1E293B"/>
+                    </a:solidFill>
+                  </a:tcPr>
+                </a:tc>
+                <a:tc>
+                  <a:txBody>
+                    <a:bodyPr/>
+                    <a:lstStyle/>
+                    <a:p>
+                      <a:pPr>
+                        <a:defRPr sz="1100">
+                          <a:solidFill>
+                            <a:srgbClr val="FFFFFF"/>
+                          </a:solidFill>
+                        </a:defRPr>
+                      </a:pPr>
+                      <a:r>
+                        <a:t>Requires Python venv</a:t>
+                      </a:r>
+                    </a:p>
+                  </a:txBody>
+                  <a:tcPr>
+                    <a:solidFill>
+                      <a:srgbClr val="1E293B"/>
+                    </a:solidFill>
+                  </a:tcPr>
+                </a:tc>
+              </a:tr>
+              <a:tr h="731520">
+                <a:tc>
+                  <a:txBody>
+                    <a:bodyPr/>
+                    <a:lstStyle/>
+                    <a:p>
+                      <a:pPr>
+                        <a:defRPr sz="1100">
+                          <a:solidFill>
+                            <a:srgbClr val="FFFFFF"/>
+                          </a:solidFill>
+                        </a:defRPr>
+                      </a:pPr>
+                      <a:r>
+                        <a:t>Execution Latency</a:t>
+                      </a:r>
+                    </a:p>
+                  </a:txBody>
+                  <a:tcPr>
+                    <a:solidFill>
+                      <a:srgbClr val="1E293B"/>
+                    </a:solidFill>
+                  </a:tcPr>
+                </a:tc>
+                <a:tc>
+                  <a:txBody>
+                    <a:bodyPr/>
+                    <a:lstStyle/>
+                    <a:p>
+                      <a:pPr>
+                        <a:defRPr sz="1100">
+                          <a:solidFill>
+                            <a:srgbClr val="06B6D4"/>
+                          </a:solidFill>
+                        </a:defRPr>
+                      </a:pPr>
+                      <a:r>
+                        <a:t>200 ms / 1,000,000 loops</a:t>
+                      </a:r>
+                    </a:p>
+                  </a:txBody>
+                  <a:tcPr>
+                    <a:solidFill>
+                      <a:srgbClr val="0F2D4B"/>
+                    </a:solidFill>
+                  </a:tcPr>
+                </a:tc>
+                <a:tc>
+                  <a:txBody>
+                    <a:bodyPr/>
+                    <a:lstStyle/>
+                    <a:p>
+                      <a:pPr>
+                        <a:defRPr sz="1100">
+                          <a:solidFill>
+                            <a:srgbClr val="FFFFFF"/>
+                          </a:solidFill>
+                        </a:defRPr>
+                      </a:pPr>
+                      <a:r>
+                        <a:t>Standard Web Latency</a:t>
+                      </a:r>
+                    </a:p>
+                  </a:txBody>
+                  <a:tcPr>
+                    <a:solidFill>
+                      <a:srgbClr val="1E293B"/>
+                    </a:solidFill>
+                  </a:tcPr>
+                </a:tc>
+                <a:tc>
+                  <a:txBody>
+                    <a:bodyPr/>
+                    <a:lstStyle/>
+                    <a:p>
+                      <a:pPr>
+                        <a:defRPr sz="1100">
+                          <a:solidFill>
+                            <a:srgbClr val="FFFFFF"/>
+                          </a:solidFill>
+                        </a:defRPr>
+                      </a:pPr>
+                      <a:r>
+                        <a:t>Multi-second loop</a:t>
+                      </a:r>
+                    </a:p>
+                  </a:txBody>
+                  <a:tcPr>
+                    <a:solidFill>
+                      <a:srgbClr val="1E293B"/>
+                    </a:solidFill>
+                  </a:tcPr>
+                </a:tc>
+              </a:tr>
+              <a:tr h="731520">
+                <a:tc>
+                  <a:txBody>
+                    <a:bodyPr/>
+                    <a:lstStyle/>
+                    <a:p>
+                      <a:pPr>
+                        <a:defRPr sz="1100">
+                          <a:solidFill>
+                            <a:srgbClr val="FFFFFF"/>
+                          </a:solidFill>
+                        </a:defRPr>
+                      </a:pPr>
+                      <a:r>
+                        <a:t>Command Safety</a:t>
+                      </a:r>
+                    </a:p>
+                  </a:txBody>
+                  <a:tcPr>
+                    <a:solidFill>
+                      <a:srgbClr val="1E293B"/>
+                    </a:solidFill>
+                  </a:tcPr>
+                </a:tc>
+                <a:tc>
+                  <a:txBody>
+                    <a:bodyPr/>
+                    <a:lstStyle/>
+                    <a:p>
+                      <a:pPr>
+                        <a:defRPr sz="1100">
+                          <a:solidFill>
+                            <a:srgbClr val="06B6D4"/>
+                          </a:solidFill>
+                        </a:defRPr>
+                      </a:pPr>
+                      <a:r>
+                        <a:t>Regex Security Sandbox</a:t>
+                      </a:r>
+                    </a:p>
+                  </a:txBody>
+                  <a:tcPr>
+                    <a:solidFill>
+                      <a:srgbClr val="0F2D4B"/>
+                    </a:solidFill>
+                  </a:tcPr>
+                </a:tc>
+                <a:tc>
+                  <a:txBody>
+                    <a:bodyPr/>
+                    <a:lstStyle/>
+                    <a:p>
+                      <a:pPr>
+                        <a:defRPr sz="1100">
+                          <a:solidFill>
+                            <a:srgbClr val="FFFFFF"/>
+                          </a:solidFill>
+                        </a:defRPr>
+                      </a:pPr>
+                      <a:r>
+                        <a:t>Unrestricted Shell</a:t>
+                      </a:r>
+                    </a:p>
+                  </a:txBody>
+                  <a:tcPr>
+                    <a:solidFill>
+                      <a:srgbClr val="1E293B"/>
+                    </a:solidFill>
+                  </a:tcPr>
+                </a:tc>
+                <a:tc>
+                  <a:txBody>
+                    <a:bodyPr/>
+                    <a:lstStyle/>
+                    <a:p>
+                      <a:pPr>
+                        <a:defRPr sz="1100">
+                          <a:solidFill>
+                            <a:srgbClr val="FFFFFF"/>
+                          </a:solidFill>
+                        </a:defRPr>
+                      </a:pPr>
+                      <a:r>
+                        <a:t>User Confirmations</a:t>
+                      </a:r>
+                    </a:p>
+                  </a:txBody>
+                  <a:tcPr>
+                    <a:solidFill>
+                      <a:srgbClr val="1E293B"/>
+                    </a:solidFill>
+                  </a:tcPr>
+                </a:tc>
+              </a:tr>
+              <a:tr h="731520">
+                <a:tc>
+                  <a:txBody>
+                    <a:bodyPr/>
+                    <a:lstStyle/>
+                    <a:p>
+                      <a:pPr>
+                        <a:defRPr sz="1100">
+                          <a:solidFill>
+                            <a:srgbClr val="FFFFFF"/>
+                          </a:solidFill>
+                        </a:defRPr>
+                      </a:pPr>
+                      <a:r>
+                        <a:t>Free AI Media</a:t>
+                      </a:r>
+                    </a:p>
+                  </a:txBody>
+                  <a:tcPr>
+                    <a:solidFill>
+                      <a:srgbClr val="1E293B"/>
+                    </a:solidFill>
+                  </a:tcPr>
+                </a:tc>
+                <a:tc>
+                  <a:txBody>
+                    <a:bodyPr/>
+                    <a:lstStyle/>
+                    <a:p>
+                      <a:pPr>
+                        <a:defRPr sz="1100">
+                          <a:solidFill>
+                            <a:srgbClr val="06B6D4"/>
+                          </a:solidFill>
+                        </a:defRPr>
+                      </a:pPr>
+                      <a:r>
+                        <a:t>FLUX.1 &amp; AnimateDiff ($0)</a:t>
+                      </a:r>
+                    </a:p>
+                  </a:txBody>
+                  <a:tcPr>
+                    <a:solidFill>
+                      <a:srgbClr val="0F2D4B"/>
+                    </a:solidFill>
+                  </a:tcPr>
+                </a:tc>
+                <a:tc>
+                  <a:txBody>
+                    <a:bodyPr/>
+                    <a:lstStyle/>
+                    <a:p>
+                      <a:pPr>
+                        <a:defRPr sz="1100">
+                          <a:solidFill>
+                            <a:srgbClr val="FFFFFF"/>
+                          </a:solidFill>
+                        </a:defRPr>
+                      </a:pPr>
+                      <a:r>
+                        <a:t>External API required</a:t>
+                      </a:r>
+                    </a:p>
+                  </a:txBody>
+                  <a:tcPr>
+                    <a:solidFill>
+                      <a:srgbClr val="1E293B"/>
+                    </a:solidFill>
+                  </a:tcPr>
+                </a:tc>
+                <a:tc>
+                  <a:txBody>
+                    <a:bodyPr/>
+                    <a:lstStyle/>
+                    <a:p>
+                      <a:pPr>
+                        <a:defRPr sz="1100">
+                          <a:solidFill>
+                            <a:srgbClr val="FFFFFF"/>
+                          </a:solidFill>
+                        </a:defRPr>
+                      </a:pPr>
+                      <a:r>
+                        <a:t>None</a:t>
+                      </a:r>
+                    </a:p>
+                  </a:txBody>
+                  <a:tcPr>
+                    <a:solidFill>
+                      <a:srgbClr val="1E293B"/>
+                    </a:solidFill>
+                  </a:tcPr>
+                </a:tc>
+              </a:tr>
+            </a:tbl>
+          </a:graphicData>
+        </a:graphic>
+      </p:graphicFrame>
     </p:spTree>
   </p:cSld>
   <p:clrMapOvr>

</xml_diff>

<commit_message>
docs: Added Hamza Abdul Karim as Author in Proposal and Presentation Decks
</commit_message>
<xml_diff>
--- a/SLIDES.pptx
+++ b/SLIDES.pptx
@@ -3213,7 +3213,20 @@
           </a:p>
           <a:p>
             <a:pPr algn="ctr">
-              <a:defRPr sz="1400">
+              <a:defRPr sz="1500" b="1">
+                <a:solidFill>
+                  <a:srgbClr val="FFFFFF"/>
+                </a:solidFill>
+                <a:latin typeface="Arial"/>
+              </a:defRPr>
+            </a:pPr>
+            <a:r>
+              <a:t>Author &amp; Lead Architect: Hamza Abdul Karim</a:t>
+            </a:r>
+          </a:p>
+          <a:p>
+            <a:pPr algn="ctr">
+              <a:defRPr sz="1300">
                 <a:solidFill>
                   <a:srgbClr val="94A3B8"/>
                 </a:solidFill>
@@ -3346,9 +3359,21 @@
           </a:p>
           <a:p>
             <a:pPr algn="ctr">
-              <a:defRPr sz="2000" b="1">
+              <a:defRPr sz="1800" b="1">
                 <a:solidFill>
                   <a:srgbClr val="06B6D4"/>
+                </a:solidFill>
+              </a:defRPr>
+            </a:pPr>
+            <a:r>
+              <a:t>Created &amp; Designed by Hamza Abdul Karim</a:t>
+            </a:r>
+          </a:p>
+          <a:p>
+            <a:pPr algn="ctr">
+              <a:defRPr sz="1600">
+                <a:solidFill>
+                  <a:srgbClr val="FFFFFF"/>
                 </a:solidFill>
               </a:defRPr>
             </a:pPr>

</xml_diff>